<commit_message>
EEE lab repot signature sheet added
</commit_message>
<xml_diff>
--- a/TOC/TOC_pre_01.pptx
+++ b/TOC/TOC_pre_01.pptx
@@ -118,6 +118,11 @@
       </a:defRPr>
     </a:lvl9pPr>
   </p:defaultTextStyle>
+  <p:extLst>
+    <p:ext uri="{EFAFB233-063F-42B5-8137-9DF3F51BA10A}">
+      <p15:sldGuideLst xmlns:p15="http://schemas.microsoft.com/office/powerpoint/2012/main"/>
+    </p:ext>
+  </p:extLst>
 </p:presentation>
 </file>
 
@@ -268,7 +273,7 @@
           <a:p>
             <a:fld id="{6444479B-705B-4489-957E-7E8A228BDFA0}" type="datetime1">
               <a:rPr lang="en-US" smtClean="0"/>
-              <a:t>01-Feb-26</a:t>
+              <a:t>24-Feb-26</a:t>
             </a:fld>
             <a:endParaRPr lang="en-US"/>
           </a:p>
@@ -466,7 +471,7 @@
           <a:p>
             <a:fld id="{C07B66AD-7C08-490A-ADA4-B47E10FB2407}" type="datetime1">
               <a:rPr lang="en-US" smtClean="0"/>
-              <a:t>01-Feb-26</a:t>
+              <a:t>24-Feb-26</a:t>
             </a:fld>
             <a:endParaRPr lang="en-US"/>
           </a:p>
@@ -674,7 +679,7 @@
           <a:p>
             <a:fld id="{05B95027-4255-49E7-9841-CD21BCC99996}" type="datetime1">
               <a:rPr lang="en-US" smtClean="0"/>
-              <a:t>01-Feb-26</a:t>
+              <a:t>24-Feb-26</a:t>
             </a:fld>
             <a:endParaRPr lang="en-US"/>
           </a:p>
@@ -872,7 +877,7 @@
           <a:p>
             <a:fld id="{9F89F774-3FA6-43B8-9241-99959C8FD463}" type="datetime1">
               <a:rPr lang="en-US" smtClean="0"/>
-              <a:t>01-Feb-26</a:t>
+              <a:t>24-Feb-26</a:t>
             </a:fld>
             <a:endParaRPr lang="en-US"/>
           </a:p>
@@ -1147,7 +1152,7 @@
           <a:p>
             <a:fld id="{F9504452-5DCC-4FE2-A5C9-8A5EF6714D65}" type="datetime1">
               <a:rPr lang="en-US" smtClean="0"/>
-              <a:t>01-Feb-26</a:t>
+              <a:t>24-Feb-26</a:t>
             </a:fld>
             <a:endParaRPr lang="en-US"/>
           </a:p>
@@ -1412,7 +1417,7 @@
           <a:p>
             <a:fld id="{E579ABC2-0180-4F3A-A895-A85BC724D472}" type="datetime1">
               <a:rPr lang="en-US" smtClean="0"/>
-              <a:t>01-Feb-26</a:t>
+              <a:t>24-Feb-26</a:t>
             </a:fld>
             <a:endParaRPr lang="en-US"/>
           </a:p>
@@ -1824,7 +1829,7 @@
           <a:p>
             <a:fld id="{6AEEA9BA-4E8F-439E-BEA4-91FBA01E3F5F}" type="datetime1">
               <a:rPr lang="en-US" smtClean="0"/>
-              <a:t>01-Feb-26</a:t>
+              <a:t>24-Feb-26</a:t>
             </a:fld>
             <a:endParaRPr lang="en-US"/>
           </a:p>
@@ -1965,7 +1970,7 @@
           <a:p>
             <a:fld id="{BE15BF18-0007-481C-AA29-413124BC3EE7}" type="datetime1">
               <a:rPr lang="en-US" smtClean="0"/>
-              <a:t>01-Feb-26</a:t>
+              <a:t>24-Feb-26</a:t>
             </a:fld>
             <a:endParaRPr lang="en-US"/>
           </a:p>
@@ -2078,7 +2083,7 @@
           <a:p>
             <a:fld id="{09BE9870-3748-43AD-B547-02A075CB4A1D}" type="datetime1">
               <a:rPr lang="en-US" smtClean="0"/>
-              <a:t>01-Feb-26</a:t>
+              <a:t>24-Feb-26</a:t>
             </a:fld>
             <a:endParaRPr lang="en-US"/>
           </a:p>
@@ -2389,7 +2394,7 @@
           <a:p>
             <a:fld id="{558E7897-33C5-4F1A-9307-D068E37F3DC7}" type="datetime1">
               <a:rPr lang="en-US" smtClean="0"/>
-              <a:t>01-Feb-26</a:t>
+              <a:t>24-Feb-26</a:t>
             </a:fld>
             <a:endParaRPr lang="en-US"/>
           </a:p>
@@ -2677,7 +2682,7 @@
           <a:p>
             <a:fld id="{82E171BA-CC09-47C8-A6DF-F5C5CB59CEEC}" type="datetime1">
               <a:rPr lang="en-US" smtClean="0"/>
-              <a:t>01-Feb-26</a:t>
+              <a:t>24-Feb-26</a:t>
             </a:fld>
             <a:endParaRPr lang="en-US"/>
           </a:p>
@@ -2918,7 +2923,7 @@
           <a:p>
             <a:fld id="{7DA38F49-B3E2-4BF0-BEC7-C30D34ABBB8D}" type="datetime1">
               <a:rPr lang="en-US" smtClean="0"/>
-              <a:t>01-Feb-26</a:t>
+              <a:t>24-Feb-26</a:t>
             </a:fld>
             <a:endParaRPr lang="en-US"/>
           </a:p>
@@ -3858,8 +3863,8 @@
           </a:p>
         </p:txBody>
       </p:sp>
-      <mc:AlternateContent xmlns:mc="http://schemas.openxmlformats.org/markup-compatibility/2006">
-        <mc:Choice xmlns:a14="http://schemas.microsoft.com/office/drawing/2010/main" Requires="a14">
+      <mc:AlternateContent xmlns:mc="http://schemas.openxmlformats.org/markup-compatibility/2006" xmlns:a14="http://schemas.microsoft.com/office/drawing/2010/main">
+        <mc:Choice Requires="a14">
           <p:sp>
             <p:nvSpPr>
               <p:cNvPr id="4" name="Rectangle 1">
@@ -4425,7 +4430,7 @@
                     <m:sSup>
                       <m:sSupPr>
                         <m:ctrlPr>
-                          <a:rPr kumimoji="0" lang="en-US" altLang="en-US" sz="2400" b="0" i="0" u="none" strike="noStrike" cap="none" normalizeH="0" baseline="0" smtClean="0">
+                          <a:rPr kumimoji="0" lang="en-US" altLang="en-US" sz="2400" b="0" i="1" u="none" strike="noStrike" cap="none" normalizeH="0" baseline="0" smtClean="0">
                             <a:ln>
                               <a:noFill/>
                             </a:ln>
@@ -4562,7 +4567,7 @@
                     <m:sSub>
                       <m:sSubPr>
                         <m:ctrlPr>
-                          <a:rPr kumimoji="0" lang="en-US" altLang="en-US" sz="2400" b="0" i="0" u="none" strike="noStrike" cap="none" normalizeH="0" baseline="0" smtClean="0">
+                          <a:rPr kumimoji="0" lang="en-US" altLang="en-US" sz="2400" b="0" i="1" u="none" strike="noStrike" cap="none" normalizeH="0" baseline="0" smtClean="0">
                             <a:ln>
                               <a:noFill/>
                             </a:ln>
@@ -4823,7 +4828,7 @@
             </p:txBody>
           </p:sp>
         </mc:Choice>
-        <mc:Fallback>
+        <mc:Fallback xmlns="">
           <p:sp>
             <p:nvSpPr>
               <p:cNvPr id="4" name="Rectangle 1">
@@ -6068,7 +6073,7 @@
                         <a:buNone/>
                       </a:pPr>
                       <a:r>
-                        <a:rPr lang="en-US" sz="1700" b="1" cap="none" spc="0">
+                        <a:rPr lang="en-US" sz="1700" b="1" cap="none" spc="0" dirty="0">
                           <a:solidFill>
                             <a:schemeClr val="tx1"/>
                           </a:solidFill>
@@ -6077,7 +6082,7 @@
                         </a:rPr>
                         <a:t>Ease of Design</a:t>
                       </a:r>
-                      <a:endParaRPr lang="en-US" sz="1700" cap="none" spc="0">
+                      <a:endParaRPr lang="en-US" sz="1700" cap="none" spc="0" dirty="0">
                         <a:solidFill>
                           <a:schemeClr val="tx1"/>
                         </a:solidFill>
@@ -9576,7 +9581,7 @@
                     <m:sSub>
                       <m:sSubPr>
                         <m:ctrlPr>
-                          <a:rPr kumimoji="0" lang="en-US" altLang="en-US" sz="2400" b="1" i="0" u="none" strike="noStrike" cap="none" normalizeH="0" baseline="0" smtClean="0">
+                          <a:rPr kumimoji="0" lang="en-US" altLang="en-US" sz="2400" b="1" i="1" u="none" strike="noStrike" cap="none" normalizeH="0" baseline="0" smtClean="0">
                             <a:ln>
                               <a:noFill/>
                             </a:ln>
@@ -9635,7 +9640,7 @@
                     <m:sSub>
                       <m:sSubPr>
                         <m:ctrlPr>
-                          <a:rPr kumimoji="0" lang="en-US" altLang="en-US" sz="2400" b="1" i="0" u="none" strike="noStrike" cap="none" normalizeH="0" baseline="0" smtClean="0">
+                          <a:rPr kumimoji="0" lang="en-US" altLang="en-US" sz="2400" b="1" i="1" u="none" strike="noStrike" cap="none" normalizeH="0" baseline="0" smtClean="0">
                             <a:ln>
                               <a:noFill/>
                             </a:ln>
@@ -9713,7 +9718,9 @@
                     <m:sSub>
                       <m:sSubPr>
                         <m:ctrlPr>
-                          <a:rPr lang="en-US" sz="2400" b="1" i="1"/>
+                          <a:rPr lang="en-US" sz="2400" b="1" i="1">
+                            <a:latin typeface="Cambria Math" panose="02040503050406030204" pitchFamily="18" charset="0"/>
+                          </a:rPr>
                         </m:ctrlPr>
                       </m:sSubPr>
                       <m:e>
@@ -9754,7 +9761,9 @@
                       </m:e>
                       <m:sub>
                         <m:r>
-                          <a:rPr lang="en-US" sz="2400" b="1"/>
+                          <a:rPr lang="en-US" sz="2400" b="1">
+                            <a:latin typeface="Cambria Math" panose="02040503050406030204" pitchFamily="18" charset="0"/>
+                          </a:rPr>
                           <m:t>1</m:t>
                         </m:r>
                       </m:sub>
@@ -10189,7 +10198,7 @@
                     <a:latin typeface="Times New Roman" panose="02020603050405020304" pitchFamily="18" charset="0"/>
                     <a:cs typeface="Times New Roman" panose="02020603050405020304" pitchFamily="18" charset="0"/>
                   </a:rPr>
-                  <a:t> Zero or more repetitions of strings from $L$.</a:t>
+                  <a:t> Zero or more repetitions of strings from L.</a:t>
                 </a:r>
               </a:p>
               <a:p>
@@ -10270,7 +10279,7 @@
                     <a:cs typeface="Times New Roman" panose="02020603050405020304" pitchFamily="18" charset="0"/>
                     <a:sym typeface="Symbol" panose="05050102010706020507" pitchFamily="18" charset="2"/>
                   </a:rPr>
-                  <a:t></a:t>
+                  <a:t>  </a:t>
                 </a:r>
                 <a:r>
                   <a:rPr kumimoji="0" lang="en-US" altLang="en-US" sz="2400" b="1" i="0" u="none" strike="noStrike" cap="none" normalizeH="0" baseline="0" dirty="0">
@@ -10391,7 +10400,7 @@
                     <m:sSub>
                       <m:sSubPr>
                         <m:ctrlPr>
-                          <a:rPr kumimoji="0" lang="en-US" altLang="en-US" sz="2400" b="1" i="0" u="none" strike="noStrike" cap="none" normalizeH="0" baseline="0" dirty="0" smtClean="0">
+                          <a:rPr kumimoji="0" lang="en-US" altLang="en-US" sz="2400" b="1" i="1" u="none" strike="noStrike" cap="none" normalizeH="0" baseline="0" dirty="0" smtClean="0">
                             <a:ln>
                               <a:noFill/>
                             </a:ln>
@@ -10450,7 +10459,7 @@
                     <m:sSub>
                       <m:sSubPr>
                         <m:ctrlPr>
-                          <a:rPr kumimoji="0" lang="en-US" altLang="en-US" sz="2400" b="1" i="0" u="none" strike="noStrike" cap="none" normalizeH="0" baseline="0" dirty="0" smtClean="0">
+                          <a:rPr kumimoji="0" lang="en-US" altLang="en-US" sz="2400" b="1" i="1" u="none" strike="noStrike" cap="none" normalizeH="0" baseline="0" dirty="0" smtClean="0">
                             <a:ln>
                               <a:noFill/>
                             </a:ln>
@@ -11416,8 +11425,8 @@
           </a:p>
         </p:txBody>
       </p:sp>
-      <mc:AlternateContent xmlns:mc="http://schemas.openxmlformats.org/markup-compatibility/2006">
-        <mc:Choice xmlns:a14="http://schemas.microsoft.com/office/drawing/2010/main" Requires="a14">
+      <mc:AlternateContent xmlns:mc="http://schemas.openxmlformats.org/markup-compatibility/2006" xmlns:a14="http://schemas.microsoft.com/office/drawing/2010/main">
+        <mc:Choice Requires="a14">
           <p:sp>
             <p:nvSpPr>
               <p:cNvPr id="4" name="Rectangle 1">
@@ -11651,7 +11660,7 @@
                     <m:sSup>
                       <m:sSupPr>
                         <m:ctrlPr>
-                          <a:rPr kumimoji="0" lang="en-US" altLang="en-US" sz="2000" b="0" i="0" u="none" strike="noStrike" cap="none" normalizeH="0" baseline="0" smtClean="0">
+                          <a:rPr kumimoji="0" lang="en-US" altLang="en-US" sz="2000" b="0" i="1" u="none" strike="noStrike" cap="none" normalizeH="0" baseline="0" smtClean="0">
                             <a:ln>
                               <a:noFill/>
                             </a:ln>
@@ -12118,7 +12127,7 @@
             </p:txBody>
           </p:sp>
         </mc:Choice>
-        <mc:Fallback>
+        <mc:Fallback xmlns="">
           <p:sp>
             <p:nvSpPr>
               <p:cNvPr id="4" name="Rectangle 1">

</xml_diff>